<commit_message>
docs: thêm video tour demo vào slide thuyết trình
</commit_message>
<xml_diff>
--- a/docs/THUYET_TRINH_DO_AN.pptx
+++ b/docs/THUYET_TRINH_DO_AN.pptx
@@ -5119,7 +5119,7 @@
                 </a:solidFill>
                 <a:latin typeface="Arial"/>
               </a:rPr>
-              <a:t>Demo giao diện hệ thống</a:t>
+              <a:t>Video demo hệ thống</a:t>
             </a:r>
           </a:p>
         </p:txBody>
@@ -5204,62 +5204,47 @@
       </p:sp>
       <p:pic>
         <p:nvPicPr>
-          <p:cNvPr id="9" name="Picture 8" descr="03_dashboard.png"/>
+          <p:cNvPr id="9" name="demo_video.mp4">
+            <a:hlinkClick r:id="" action="ppaction://media"/>
+          </p:cNvPr>
           <p:cNvPicPr>
             <a:picLocks noChangeAspect="1"/>
           </p:cNvPicPr>
-          <p:nvPr/>
+          <p:nvPr>
+            <a:videoFile r:link="rId3"/>
+            <p:extLst>
+              <p:ext uri="{DAA4B4D4-6D71-4841-9C94-3DE7FCFB9230}">
+                <p14:media xmlns:p14="http://schemas.microsoft.com/office/powerpoint/2010/main" r:embed="rId2"/>
+              </p:ext>
+            </p:extLst>
+          </p:nvPr>
         </p:nvPicPr>
         <p:blipFill>
-          <a:blip r:embed="rId2"/>
+          <a:blip r:embed="rId4"/>
           <a:stretch>
             <a:fillRect/>
           </a:stretch>
         </p:blipFill>
         <p:spPr>
           <a:xfrm>
-            <a:off x="548640" y="2217420"/>
-            <a:ext cx="5486400" cy="3429000"/>
+            <a:off x="1892807" y="1517904"/>
+            <a:ext cx="8412480" cy="4736592"/>
           </a:xfrm>
           <a:prstGeom prst="rect">
             <a:avLst/>
           </a:prstGeom>
         </p:spPr>
       </p:pic>
-      <p:pic>
-        <p:nvPicPr>
-          <p:cNvPr id="10" name="Picture 9" descr="09_ai_result.png"/>
-          <p:cNvPicPr>
-            <a:picLocks noChangeAspect="1"/>
-          </p:cNvPicPr>
-          <p:nvPr/>
-        </p:nvPicPr>
-        <p:blipFill>
-          <a:blip r:embed="rId3"/>
-          <a:stretch>
-            <a:fillRect/>
-          </a:stretch>
-        </p:blipFill>
-        <p:spPr>
-          <a:xfrm>
-            <a:off x="6309360" y="2217420"/>
-            <a:ext cx="5486400" cy="3429000"/>
-          </a:xfrm>
-          <a:prstGeom prst="rect">
-            <a:avLst/>
-          </a:prstGeom>
-        </p:spPr>
-      </p:pic>
-      <p:sp>
-        <p:nvSpPr>
-          <p:cNvPr id="11" name="TextBox 10"/>
+      <p:sp>
+        <p:nvSpPr>
+          <p:cNvPr id="10" name="TextBox 9"/>
           <p:cNvSpPr txBox="1"/>
           <p:nvPr/>
         </p:nvSpPr>
         <p:spPr>
           <a:xfrm>
-            <a:off x="868680" y="6172200"/>
-            <a:ext cx="5029200" cy="365760"/>
+            <a:off x="868680" y="6355080"/>
+            <a:ext cx="10424160" cy="365760"/>
           </a:xfrm>
           <a:prstGeom prst="rect">
             <a:avLst/>
@@ -5278,52 +5263,13 @@
               </a:lnSpc>
             </a:pPr>
             <a:r>
-              <a:rPr sz="1200" b="0" i="1">
+              <a:rPr sz="1100" b="0" i="1">
                 <a:solidFill>
                   <a:srgbClr val="64748B"/>
                 </a:solidFill>
                 <a:latin typeface="Arial"/>
               </a:rPr>
-              <a:t>Dashboard quản lý</a:t>
-            </a:r>
-          </a:p>
-        </p:txBody>
-      </p:sp>
-      <p:sp>
-        <p:nvSpPr>
-          <p:cNvPr id="12" name="TextBox 11"/>
-          <p:cNvSpPr txBox="1"/>
-          <p:nvPr/>
-        </p:nvSpPr>
-        <p:spPr>
-          <a:xfrm>
-            <a:off x="6400800" y="6172200"/>
-            <a:ext cx="5029200" cy="365760"/>
-          </a:xfrm>
-          <a:prstGeom prst="rect">
-            <a:avLst/>
-          </a:prstGeom>
-          <a:noFill/>
-        </p:spPr>
-        <p:txBody>
-          <a:bodyPr wrap="square" anchor="t">
-            <a:spAutoFit/>
-          </a:bodyPr>
-          <a:lstStyle/>
-          <a:p>
-            <a:pPr algn="ctr">
-              <a:lnSpc>
-                <a:spcPct val="110000"/>
-              </a:lnSpc>
-            </a:pPr>
-            <a:r>
-              <a:rPr sz="1200" b="0" i="1">
-                <a:solidFill>
-                  <a:srgbClr val="64748B"/>
-                </a:solidFill>
-                <a:latin typeface="Arial"/>
-              </a:rPr>
-              <a:t>Kết quả AI gợi ý nhân viên</a:t>
+              <a:t>Video tham quan các màn hình chính — bấm để phát khi thuyết trình</a:t>
             </a:r>
           </a:p>
         </p:txBody>
@@ -5333,6 +5279,28 @@
   <p:clrMapOvr>
     <a:masterClrMapping/>
   </p:clrMapOvr>
+  <p:timing>
+    <p:tnLst>
+      <p:par>
+        <p:cTn id="1" dur="indefinite" restart="never" nodeType="tmRoot">
+          <p:childTnLst>
+            <p:video>
+              <p:cMediaNode vol="80000">
+                <p:cTn id="2" fill="hold" display="0">
+                  <p:stCondLst>
+                    <p:cond delay="indefinite"/>
+                  </p:stCondLst>
+                </p:cTn>
+                <p:tgtEl>
+                  <p:spTgt spid="9"/>
+                </p:tgtEl>
+              </p:cMediaNode>
+            </p:video>
+          </p:childTnLst>
+        </p:cTn>
+      </p:par>
+    </p:tnLst>
+  </p:timing>
   <p:transition spd="med">
     <p:fade/>
   </p:transition>

</xml_diff>